<commit_message>
Unit 19: add videos
11 videos embedded click-to-play (youtube-nocookie) in their lessons and on a
new 7. Videos page with 'watch and think' questions: the scheme of work and
deck links, plus official uploads of the teacher's MP4s (Warriors of the Net,
Cisco Anatomy of an Attack, Cisco Internet of Everything) and the Port of Long
Beach terminal film with the VectorUSA/Cisco case study. Original MP4s are not
re-hosted. Teacher deck notes say when to play each video.

Co-Authored-By: Claude Opus 5.5 <noreply@anthropic.com>
</commit_message>
<xml_diff>
--- a/docs/unit19/teacher/Unit19-Computer-Networking-Teacher-Deck.pptx
+++ b/docs/unit19/teacher/Unit19-Computer-Networking-Teacher-Deck.pptx
@@ -805,7 +805,8 @@
               <a:rPr lang="en-US" dirty="0"/>
               <a:t>A.D1 needs benefits AND drawbacks for all three models, tested against the four factors, each backed by a realistic example, leading to a justified conclusion.
 Model the difference between describing and evaluating with one worked paragraph using a different client (not the assignment wording).
-Support: sentence stems (because… therefore… however…). Stretch: hybrid models, e.g. client/server plus cloud SaaS.</a:t>
+Support: sentence stems (because… therefore… however…). Stretch: hybrid models, e.g. client/server plus cloud SaaS.
+Video (lesson A1c): What is a thin client? Use it before the thin-client discussion.</a:t>
             </a:r>
             <a:endParaRPr lang="en-US" dirty="0"/>
           </a:p>
@@ -896,7 +897,8 @@
               <a:t>Show the cloud responsibility chart: the further right, the less the customer manages.
 Ask: what is the noisy neighbour problem in public cloud?
 Link BYOD to Cyber Essentials (employer feedback on the brief) and to guest VLANs later in B1.
-Homework: Assignment 1 trends section research.</a:t>
+Homework: Assignment 1 trends section research.
+Videos (lesson A1d): Cisco Internet of Everything: Circle Story (1 min starter), AWS What is cloud computing?, Cloud computing in 6 minutes, What is SDN?, Intro to SAN technologies.</a:t>
             </a:r>
             <a:endParaRPr lang="en-US" dirty="0"/>
           </a:p>
@@ -1167,7 +1169,8 @@
               <a:t>Teach the purpose of layering: modular design, interoperability, troubleshooting.
 Map devices to layers: hub/cable (1), switch (2), router (3); ports at layer 4.
 TCP vs UDP: handshake, acknowledgements, re-sending vs speed.
-Stretch: why the session and presentation functions sit inside the TCP/IP application layer.</a:t>
+Stretch: why the session and presentation functions sit inside the TCP/IP application layer.
+Video (lesson A3): Warriors of the Net, Ericsson (12:57). Show in full; pause at the router, switch and firewall scenes and ask which OSI layer each works at.</a:t>
             </a:r>
             <a:endParaRPr lang="en-US" dirty="0"/>
           </a:p>
@@ -1706,7 +1709,8 @@
               <a:rPr lang="en-US" dirty="0"/>
               <a:t>Use the dental practice example on the Learn page (a different client from the assignment).
 Discuss trade-offs explicitly: redundancy costs money; security affects ease of use.
-Stretch: failure domains and link aggregation (EtherChannel) in hierarchical designs.</a:t>
+Stretch: failure domains and link aggregation (EtherChannel) in hierarchical designs.
+Video (lesson B1a): Port of Long Beach automated container terminal, with the VectorUSA and Cisco case study link: which design aims matter most in a port that stops if the network fails?</a:t>
             </a:r>
             <a:endParaRPr lang="en-US" dirty="0"/>
           </a:p>
@@ -2065,7 +2069,8 @@
               <a:rPr lang="en-US" dirty="0"/>
               <a:t>Appendix A needs users, groups and folder permissions with different access for others: students must work out their own numbers.
 Use the college policies pack (password, remote access, network security) as real examples of policy documents.
-Stretch: sticky bit and setgid for shared folders.</a:t>
+Stretch: sticky bit and setgid for shared folders.
+Video (lesson B3): Cisco Anatomy of an Attack (4 min). Discuss which password, access and audit controls would have stopped the attacker sooner.</a:t>
             </a:r>
             <a:endParaRPr lang="en-US" dirty="0"/>
           </a:p>
@@ -3234,7 +3239,8 @@
               <a:t>Teach: PAN, LAN, WLAN, MAN, WAN, SAN by scale and by who manages them. Emphasise the NEED: communicate, share data, share resources, collaborate.
 Question: why would a listed building choose a WLAN? Why does a hospital data centre use a SAN?
 Support: give students the types table on the Learn page (A1a). Stretch: add the cost and security implications of each choice.
-Workbook A1a. Practical: Lab 1 Packet Tracer tour. Homework: complete the NetAcad Packet Tracer short course.</a:t>
+Workbook A1a. Practical: Lab 1 Packet Tracer tour. Homework: complete the NetAcad Packet Tracer short course.
+Videos (site page 7, lesson A1a): Types of computer networks (LAN, MAN, WAN) and Internet vs intranet vs extranet.</a:t>
             </a:r>
             <a:endParaRPr lang="en-US" dirty="0"/>
           </a:p>
@@ -25713,7 +25719,7 @@
                 <a:ea typeface="Calibri" pitchFamily="34" charset="-122"/>
                 <a:cs typeface="Calibri" pitchFamily="34" charset="-120"/>
               </a:rPr>
-              <a:t>Link for Teams: nigeriastudentcenter.github.io/btech/unit19/start.html · No student accounts; work saves in the browser with download backups.</a:t>
+              <a:t>Plus 7. Videos: 11 embedded videos. Link for Teams: nigeriastudentcenter.github.io/btech/unit19/start.html · No accounts; work saves in the browser.</a:t>
             </a:r>
             <a:endParaRPr lang="en-US" sz="1000" dirty="0"/>
           </a:p>

</xml_diff>